<commit_message>
Align course authorities and portal mappings
</commit_message>
<xml_diff>
--- a/STARLAB_Slide_Decks_All/06_Pilot_Testing_2.0.pptx
+++ b/STARLAB_Slide_Decks_All/06_Pilot_Testing_2.0.pptx
@@ -3076,7 +3076,7 @@
             </a:br>
             <a:r>
               <a:rPr lang="en-US"/>
-              <a:t>This slide is for teachers as much as students. Make the gatekeeping explicit: students move to full data collection based on readiness, not just the calendar.</a:t>
+              <a:t>This slide is for teachers as much as students. The Project Approval Tracker is the official record. Students move to systematic data collection only when the tracker records Approved for Systematic Data Collection, not simply because the calendar advances.</a:t>
             </a:r>
             <a:br>
               <a:rPr lang="en-US"/>
@@ -3093,7 +3093,7 @@
             </a:br>
             <a:r>
               <a:rPr lang="en-US"/>
-              <a:t>Use with Unit 3 Student Handout 5: Method Revision Decision Chart and Unit 3 Appendix C: Safety Check Before Testing. This checkpoint should happen before students begin systematic data collection.</a:t>
+              <a:t>Use with Unit 3 Student Handout 5: Method Revision Decision Chart and Unit 3 Appendix C: Safety Check Before Testing. Record the exact tracker status before students begin systematic data collection.</a:t>
             </a:r>
             <a:endParaRPr/>
           </a:p>
@@ -15504,7 +15504,7 @@
                 <a:cs typeface="Arial"/>
                 <a:sym typeface="Arial"/>
               </a:rPr>
-              <a:t>Approval language</a:t>
+              <a:t>Official tracker status examples</a:t>
             </a:r>
             <a:endParaRPr b="0" i="0" sz="1400" u="none" cap="none" strike="noStrike">
               <a:solidFill>
@@ -15567,7 +15567,7 @@
                 <a:cs typeface="Arial"/>
                 <a:sym typeface="Arial"/>
               </a:rPr>
-              <a:t>Approved</a:t>
+              <a:t>Approved for Systematic Data Collection</a:t>
             </a:r>
             <a:endParaRPr b="0" i="0" sz="1350" u="none" cap="none" strike="noStrike">
               <a:solidFill>
@@ -15604,7 +15604,7 @@
                 <a:cs typeface="Arial"/>
                 <a:sym typeface="Arial"/>
               </a:rPr>
-              <a:t>Approved with revisions</a:t>
+              <a:t>Approved With Modifications</a:t>
             </a:r>
             <a:endParaRPr b="0" i="0" sz="1350" u="none" cap="none" strike="noStrike">
               <a:solidFill>
@@ -15641,7 +15641,7 @@
                 <a:cs typeface="Arial"/>
                 <a:sym typeface="Arial"/>
               </a:rPr>
-              <a:t>Needs another pilot</a:t>
+              <a:t>Needs Revision</a:t>
             </a:r>
             <a:endParaRPr b="0" i="0" sz="1350" u="none" cap="none" strike="noStrike">
               <a:solidFill>
@@ -15678,7 +15678,7 @@
                 <a:cs typeface="Arial"/>
                 <a:sym typeface="Arial"/>
               </a:rPr>
-              <a:t>Needs safety review</a:t>
+              <a:t>Needs Safety Review / Needs Ethics Review</a:t>
             </a:r>
             <a:endParaRPr b="0" i="0" sz="1350" u="none" cap="none" strike="noStrike">
               <a:solidFill>
@@ -15715,7 +15715,7 @@
                 <a:cs typeface="Arial"/>
                 <a:sym typeface="Arial"/>
               </a:rPr>
-              <a:t>Needs redesign</a:t>
+              <a:t>Needs Mentor Review / Not Approved in Current Form</a:t>
             </a:r>
             <a:endParaRPr b="0" i="0" sz="1350" u="none" cap="none" strike="noStrike">
               <a:solidFill>

</xml_diff>